<commit_message>
NGAL line plots and update imputation pipeline analysis
</commit_message>
<xml_diff>
--- a/exploratory_analysis/plots/compare_plots.pptx
+++ b/exploratory_analysis/plots/compare_plots.pptx
@@ -16,6 +16,9 @@
     <p:sldId id="264" r:id="rId10"/>
     <p:sldId id="265" r:id="rId11"/>
     <p:sldId id="266" r:id="rId12"/>
+    <p:sldId id="267" r:id="rId13"/>
+    <p:sldId id="268" r:id="rId14"/>
+    <p:sldId id="269" r:id="rId15"/>
   </p:sldIdLst>
   <p:sldSz cx="12192000" cy="6858000"/>
   <p:notesSz cx="6858000" cy="9144000"/>
@@ -269,7 +272,7 @@
           <a:p>
             <a:fld id="{0A9A78ED-B98F-42E9-8346-8CC44BF90042}" type="datetimeFigureOut">
               <a:rPr lang="en-US" smtClean="0"/>
-              <a:t>2/18/2026</a:t>
+              <a:t>2/26/2026</a:t>
             </a:fld>
             <a:endParaRPr lang="en-US"/>
           </a:p>
@@ -467,7 +470,7 @@
           <a:p>
             <a:fld id="{0A9A78ED-B98F-42E9-8346-8CC44BF90042}" type="datetimeFigureOut">
               <a:rPr lang="en-US" smtClean="0"/>
-              <a:t>2/18/2026</a:t>
+              <a:t>2/26/2026</a:t>
             </a:fld>
             <a:endParaRPr lang="en-US"/>
           </a:p>
@@ -675,7 +678,7 @@
           <a:p>
             <a:fld id="{0A9A78ED-B98F-42E9-8346-8CC44BF90042}" type="datetimeFigureOut">
               <a:rPr lang="en-US" smtClean="0"/>
-              <a:t>2/18/2026</a:t>
+              <a:t>2/26/2026</a:t>
             </a:fld>
             <a:endParaRPr lang="en-US"/>
           </a:p>
@@ -873,7 +876,7 @@
           <a:p>
             <a:fld id="{0A9A78ED-B98F-42E9-8346-8CC44BF90042}" type="datetimeFigureOut">
               <a:rPr lang="en-US" smtClean="0"/>
-              <a:t>2/18/2026</a:t>
+              <a:t>2/26/2026</a:t>
             </a:fld>
             <a:endParaRPr lang="en-US"/>
           </a:p>
@@ -1148,7 +1151,7 @@
           <a:p>
             <a:fld id="{0A9A78ED-B98F-42E9-8346-8CC44BF90042}" type="datetimeFigureOut">
               <a:rPr lang="en-US" smtClean="0"/>
-              <a:t>2/18/2026</a:t>
+              <a:t>2/26/2026</a:t>
             </a:fld>
             <a:endParaRPr lang="en-US"/>
           </a:p>
@@ -1413,7 +1416,7 @@
           <a:p>
             <a:fld id="{0A9A78ED-B98F-42E9-8346-8CC44BF90042}" type="datetimeFigureOut">
               <a:rPr lang="en-US" smtClean="0"/>
-              <a:t>2/18/2026</a:t>
+              <a:t>2/26/2026</a:t>
             </a:fld>
             <a:endParaRPr lang="en-US"/>
           </a:p>
@@ -1825,7 +1828,7 @@
           <a:p>
             <a:fld id="{0A9A78ED-B98F-42E9-8346-8CC44BF90042}" type="datetimeFigureOut">
               <a:rPr lang="en-US" smtClean="0"/>
-              <a:t>2/18/2026</a:t>
+              <a:t>2/26/2026</a:t>
             </a:fld>
             <a:endParaRPr lang="en-US"/>
           </a:p>
@@ -1966,7 +1969,7 @@
           <a:p>
             <a:fld id="{0A9A78ED-B98F-42E9-8346-8CC44BF90042}" type="datetimeFigureOut">
               <a:rPr lang="en-US" smtClean="0"/>
-              <a:t>2/18/2026</a:t>
+              <a:t>2/26/2026</a:t>
             </a:fld>
             <a:endParaRPr lang="en-US"/>
           </a:p>
@@ -2079,7 +2082,7 @@
           <a:p>
             <a:fld id="{0A9A78ED-B98F-42E9-8346-8CC44BF90042}" type="datetimeFigureOut">
               <a:rPr lang="en-US" smtClean="0"/>
-              <a:t>2/18/2026</a:t>
+              <a:t>2/26/2026</a:t>
             </a:fld>
             <a:endParaRPr lang="en-US"/>
           </a:p>
@@ -2390,7 +2393,7 @@
           <a:p>
             <a:fld id="{0A9A78ED-B98F-42E9-8346-8CC44BF90042}" type="datetimeFigureOut">
               <a:rPr lang="en-US" smtClean="0"/>
-              <a:t>2/18/2026</a:t>
+              <a:t>2/26/2026</a:t>
             </a:fld>
             <a:endParaRPr lang="en-US"/>
           </a:p>
@@ -2678,7 +2681,7 @@
           <a:p>
             <a:fld id="{0A9A78ED-B98F-42E9-8346-8CC44BF90042}" type="datetimeFigureOut">
               <a:rPr lang="en-US" smtClean="0"/>
-              <a:t>2/18/2026</a:t>
+              <a:t>2/26/2026</a:t>
             </a:fld>
             <a:endParaRPr lang="en-US"/>
           </a:p>
@@ -2919,7 +2922,7 @@
           <a:p>
             <a:fld id="{0A9A78ED-B98F-42E9-8346-8CC44BF90042}" type="datetimeFigureOut">
               <a:rPr lang="en-US" smtClean="0"/>
-              <a:t>2/18/2026</a:t>
+              <a:t>2/26/2026</a:t>
             </a:fld>
             <a:endParaRPr lang="en-US"/>
           </a:p>
@@ -3617,6 +3620,346 @@
     <p:extLst>
       <p:ext uri="{BB962C8B-B14F-4D97-AF65-F5344CB8AC3E}">
         <p14:creationId xmlns:p14="http://schemas.microsoft.com/office/powerpoint/2010/main" val="1377604831"/>
+      </p:ext>
+    </p:extLst>
+  </p:cSld>
+  <p:clrMapOvr>
+    <a:masterClrMapping/>
+  </p:clrMapOvr>
+</p:sld>
+</file>
+
+<file path=ppt/slides/slide12.xml><?xml version="1.0" encoding="utf-8"?>
+<p:sld xmlns:a="http://schemas.openxmlformats.org/drawingml/2006/main" xmlns:r="http://schemas.openxmlformats.org/officeDocument/2006/relationships" xmlns:p="http://schemas.openxmlformats.org/presentationml/2006/main">
+  <p:cSld>
+    <p:spTree>
+      <p:nvGrpSpPr>
+        <p:cNvPr id="1" name=""/>
+        <p:cNvGrpSpPr/>
+        <p:nvPr/>
+      </p:nvGrpSpPr>
+      <p:grpSpPr>
+        <a:xfrm>
+          <a:off x="0" y="0"/>
+          <a:ext cx="0" cy="0"/>
+          <a:chOff x="0" y="0"/>
+          <a:chExt cx="0" cy="0"/>
+        </a:xfrm>
+      </p:grpSpPr>
+      <p:sp>
+        <p:nvSpPr>
+          <p:cNvPr id="2" name="Title 1">
+            <a:extLst>
+              <a:ext uri="{FF2B5EF4-FFF2-40B4-BE49-F238E27FC236}">
+                <a16:creationId xmlns:a16="http://schemas.microsoft.com/office/drawing/2014/main" id="{F4806488-478F-7C11-1EB2-6395CA6A1A91}"/>
+              </a:ext>
+            </a:extLst>
+          </p:cNvPr>
+          <p:cNvSpPr>
+            <a:spLocks noGrp="1"/>
+          </p:cNvSpPr>
+          <p:nvPr>
+            <p:ph type="title"/>
+          </p:nvPr>
+        </p:nvSpPr>
+        <p:spPr/>
+        <p:txBody>
+          <a:bodyPr/>
+          <a:lstStyle/>
+          <a:p>
+            <a:r>
+              <a:rPr lang="en-US" dirty="0"/>
+              <a:t>Standardized NGAL from Baseline Over Time for AKI and no AKI populations</a:t>
+            </a:r>
+          </a:p>
+        </p:txBody>
+      </p:sp>
+      <p:pic>
+        <p:nvPicPr>
+          <p:cNvPr id="5" name="Content Placeholder 4">
+            <a:extLst>
+              <a:ext uri="{FF2B5EF4-FFF2-40B4-BE49-F238E27FC236}">
+                <a16:creationId xmlns:a16="http://schemas.microsoft.com/office/drawing/2014/main" id="{41EAC5F1-CEA7-990D-D387-76BD68C2AE82}"/>
+              </a:ext>
+            </a:extLst>
+          </p:cNvPr>
+          <p:cNvPicPr>
+            <a:picLocks noGrp="1" noChangeAspect="1"/>
+          </p:cNvPicPr>
+          <p:nvPr>
+            <p:ph idx="1"/>
+          </p:nvPr>
+        </p:nvPicPr>
+        <p:blipFill>
+          <a:blip r:embed="rId2">
+            <a:extLst>
+              <a:ext uri="{28A0092B-C50C-407E-A947-70E740481C1C}">
+                <a14:useLocalDpi xmlns:a14="http://schemas.microsoft.com/office/drawing/2010/main" val="0"/>
+              </a:ext>
+            </a:extLst>
+          </a:blip>
+          <a:stretch>
+            <a:fillRect/>
+          </a:stretch>
+        </p:blipFill>
+        <p:spPr>
+          <a:xfrm>
+            <a:off x="1744662" y="1745624"/>
+            <a:ext cx="4351338" cy="4351338"/>
+          </a:xfrm>
+        </p:spPr>
+      </p:pic>
+      <p:pic>
+        <p:nvPicPr>
+          <p:cNvPr id="7" name="Picture 6">
+            <a:extLst>
+              <a:ext uri="{FF2B5EF4-FFF2-40B4-BE49-F238E27FC236}">
+                <a16:creationId xmlns:a16="http://schemas.microsoft.com/office/drawing/2014/main" id="{0FB9E1B0-4B5A-6AD9-2547-A0C5C8B9A308}"/>
+              </a:ext>
+            </a:extLst>
+          </p:cNvPr>
+          <p:cNvPicPr>
+            <a:picLocks noChangeAspect="1"/>
+          </p:cNvPicPr>
+          <p:nvPr/>
+        </p:nvPicPr>
+        <p:blipFill>
+          <a:blip r:embed="rId3">
+            <a:extLst>
+              <a:ext uri="{28A0092B-C50C-407E-A947-70E740481C1C}">
+                <a14:useLocalDpi xmlns:a14="http://schemas.microsoft.com/office/drawing/2010/main" val="0"/>
+              </a:ext>
+            </a:extLst>
+          </a:blip>
+          <a:stretch>
+            <a:fillRect/>
+          </a:stretch>
+        </p:blipFill>
+        <p:spPr>
+          <a:xfrm>
+            <a:off x="6408821" y="1745624"/>
+            <a:ext cx="4572000" cy="4572000"/>
+          </a:xfrm>
+          <a:prstGeom prst="rect">
+            <a:avLst/>
+          </a:prstGeom>
+        </p:spPr>
+      </p:pic>
+    </p:spTree>
+    <p:extLst>
+      <p:ext uri="{BB962C8B-B14F-4D97-AF65-F5344CB8AC3E}">
+        <p14:creationId xmlns:p14="http://schemas.microsoft.com/office/powerpoint/2010/main" val="3393874461"/>
+      </p:ext>
+    </p:extLst>
+  </p:cSld>
+  <p:clrMapOvr>
+    <a:masterClrMapping/>
+  </p:clrMapOvr>
+</p:sld>
+</file>
+
+<file path=ppt/slides/slide13.xml><?xml version="1.0" encoding="utf-8"?>
+<p:sld xmlns:a="http://schemas.openxmlformats.org/drawingml/2006/main" xmlns:r="http://schemas.openxmlformats.org/officeDocument/2006/relationships" xmlns:p="http://schemas.openxmlformats.org/presentationml/2006/main">
+  <p:cSld>
+    <p:spTree>
+      <p:nvGrpSpPr>
+        <p:cNvPr id="1" name=""/>
+        <p:cNvGrpSpPr/>
+        <p:nvPr/>
+      </p:nvGrpSpPr>
+      <p:grpSpPr>
+        <a:xfrm>
+          <a:off x="0" y="0"/>
+          <a:ext cx="0" cy="0"/>
+          <a:chOff x="0" y="0"/>
+          <a:chExt cx="0" cy="0"/>
+        </a:xfrm>
+      </p:grpSpPr>
+      <p:sp>
+        <p:nvSpPr>
+          <p:cNvPr id="2" name="Title 1">
+            <a:extLst>
+              <a:ext uri="{FF2B5EF4-FFF2-40B4-BE49-F238E27FC236}">
+                <a16:creationId xmlns:a16="http://schemas.microsoft.com/office/drawing/2014/main" id="{296B5EF6-AD4E-DB4C-28E5-17C07B557861}"/>
+              </a:ext>
+            </a:extLst>
+          </p:cNvPr>
+          <p:cNvSpPr>
+            <a:spLocks noGrp="1"/>
+          </p:cNvSpPr>
+          <p:nvPr>
+            <p:ph type="title"/>
+          </p:nvPr>
+        </p:nvSpPr>
+        <p:spPr/>
+        <p:txBody>
+          <a:bodyPr/>
+          <a:lstStyle/>
+          <a:p>
+            <a:r>
+              <a:rPr lang="en-US" dirty="0"/>
+              <a:t>Mediation Analysis when using standardized NGAL at T3 as the mediating variable</a:t>
+            </a:r>
+          </a:p>
+        </p:txBody>
+      </p:sp>
+      <p:sp>
+        <p:nvSpPr>
+          <p:cNvPr id="3" name="Content Placeholder 2">
+            <a:extLst>
+              <a:ext uri="{FF2B5EF4-FFF2-40B4-BE49-F238E27FC236}">
+                <a16:creationId xmlns:a16="http://schemas.microsoft.com/office/drawing/2014/main" id="{656AB8C0-D585-C670-017C-DFC0E35ADA38}"/>
+              </a:ext>
+            </a:extLst>
+          </p:cNvPr>
+          <p:cNvSpPr>
+            <a:spLocks noGrp="1"/>
+          </p:cNvSpPr>
+          <p:nvPr>
+            <p:ph idx="1"/>
+          </p:nvPr>
+        </p:nvSpPr>
+        <p:spPr/>
+        <p:txBody>
+          <a:bodyPr/>
+          <a:lstStyle/>
+          <a:p>
+            <a:r>
+              <a:rPr lang="en-US" dirty="0"/>
+              <a:t>Total effect: 0.17 (0.00, 0.36)</a:t>
+            </a:r>
+          </a:p>
+          <a:p>
+            <a:r>
+              <a:rPr lang="en-US" dirty="0"/>
+              <a:t>Indirect effect: 0.00 (-0.19, 0.20)</a:t>
+            </a:r>
+          </a:p>
+          <a:p>
+            <a:r>
+              <a:rPr lang="en-US" dirty="0"/>
+              <a:t>Direct effect: 0.16 (0.02, 0.32)</a:t>
+            </a:r>
+          </a:p>
+          <a:p>
+            <a:endParaRPr lang="en-US" dirty="0"/>
+          </a:p>
+          <a:p>
+            <a:endParaRPr lang="en-US" dirty="0"/>
+          </a:p>
+        </p:txBody>
+      </p:sp>
+    </p:spTree>
+    <p:extLst>
+      <p:ext uri="{BB962C8B-B14F-4D97-AF65-F5344CB8AC3E}">
+        <p14:creationId xmlns:p14="http://schemas.microsoft.com/office/powerpoint/2010/main" val="3385691530"/>
+      </p:ext>
+    </p:extLst>
+  </p:cSld>
+  <p:clrMapOvr>
+    <a:masterClrMapping/>
+  </p:clrMapOvr>
+</p:sld>
+</file>
+
+<file path=ppt/slides/slide14.xml><?xml version="1.0" encoding="utf-8"?>
+<p:sld xmlns:a="http://schemas.openxmlformats.org/drawingml/2006/main" xmlns:r="http://schemas.openxmlformats.org/officeDocument/2006/relationships" xmlns:p="http://schemas.openxmlformats.org/presentationml/2006/main">
+  <p:cSld>
+    <p:spTree>
+      <p:nvGrpSpPr>
+        <p:cNvPr id="1" name=""/>
+        <p:cNvGrpSpPr/>
+        <p:nvPr/>
+      </p:nvGrpSpPr>
+      <p:grpSpPr>
+        <a:xfrm>
+          <a:off x="0" y="0"/>
+          <a:ext cx="0" cy="0"/>
+          <a:chOff x="0" y="0"/>
+          <a:chExt cx="0" cy="0"/>
+        </a:xfrm>
+      </p:grpSpPr>
+      <p:sp>
+        <p:nvSpPr>
+          <p:cNvPr id="2" name="Title 1">
+            <a:extLst>
+              <a:ext uri="{FF2B5EF4-FFF2-40B4-BE49-F238E27FC236}">
+                <a16:creationId xmlns:a16="http://schemas.microsoft.com/office/drawing/2014/main" id="{5C36F220-07D7-2702-0D83-56DA6F3EDFD3}"/>
+              </a:ext>
+            </a:extLst>
+          </p:cNvPr>
+          <p:cNvSpPr>
+            <a:spLocks noGrp="1"/>
+          </p:cNvSpPr>
+          <p:nvPr>
+            <p:ph type="title"/>
+          </p:nvPr>
+        </p:nvSpPr>
+        <p:spPr/>
+        <p:txBody>
+          <a:bodyPr/>
+          <a:lstStyle/>
+          <a:p>
+            <a:endParaRPr lang="en-US"/>
+          </a:p>
+        </p:txBody>
+      </p:sp>
+      <p:sp>
+        <p:nvSpPr>
+          <p:cNvPr id="3" name="Content Placeholder 2">
+            <a:extLst>
+              <a:ext uri="{FF2B5EF4-FFF2-40B4-BE49-F238E27FC236}">
+                <a16:creationId xmlns:a16="http://schemas.microsoft.com/office/drawing/2014/main" id="{23F65D2F-9D96-3CBE-73A1-252C9B28A634}"/>
+              </a:ext>
+            </a:extLst>
+          </p:cNvPr>
+          <p:cNvSpPr>
+            <a:spLocks noGrp="1"/>
+          </p:cNvSpPr>
+          <p:nvPr>
+            <p:ph idx="1"/>
+          </p:nvPr>
+        </p:nvSpPr>
+        <p:spPr/>
+        <p:txBody>
+          <a:bodyPr/>
+          <a:lstStyle/>
+          <a:p>
+            <a:r>
+              <a:rPr lang="en-US" dirty="0"/>
+              <a:t>Effect of nadir DO2 and X-clamp duration on standardized NGAL at T3</a:t>
+            </a:r>
+          </a:p>
+          <a:p>
+            <a:r>
+              <a:rPr lang="en-US" dirty="0"/>
+              <a:t>0.12 (-0.03, 0.25)</a:t>
+            </a:r>
+          </a:p>
+          <a:p>
+            <a:r>
+              <a:rPr lang="en-US" dirty="0"/>
+              <a:t>These values of standardized NGAL are scaled by the standard deviation, which is about 36,000. An equivalent interval would be</a:t>
+            </a:r>
+          </a:p>
+          <a:p>
+            <a:r>
+              <a:rPr lang="en-US" dirty="0"/>
+              <a:t>4,300 (-1,100, 9,000)</a:t>
+            </a:r>
+          </a:p>
+          <a:p>
+            <a:r>
+              <a:rPr lang="en-US" dirty="0"/>
+              <a:t>This estimate is based off of the imputed values of standardized NGAL for whom we have no measurements of biomarker data, which introduces greater amounts of uncertainty</a:t>
+            </a:r>
+          </a:p>
+        </p:txBody>
+      </p:sp>
+    </p:spTree>
+    <p:extLst>
+      <p:ext uri="{BB962C8B-B14F-4D97-AF65-F5344CB8AC3E}">
+        <p14:creationId xmlns:p14="http://schemas.microsoft.com/office/powerpoint/2010/main" val="1134780764"/>
       </p:ext>
     </p:extLst>
   </p:cSld>

</xml_diff>

<commit_message>
add analysis when using stand NGAL at T4 as mediating variable
</commit_message>
<xml_diff>
--- a/exploratory_analysis/plots/compare_plots.pptx
+++ b/exploratory_analysis/plots/compare_plots.pptx
@@ -17,8 +17,12 @@
     <p:sldId id="265" r:id="rId11"/>
     <p:sldId id="266" r:id="rId12"/>
     <p:sldId id="267" r:id="rId13"/>
-    <p:sldId id="268" r:id="rId14"/>
-    <p:sldId id="269" r:id="rId15"/>
+    <p:sldId id="270" r:id="rId14"/>
+    <p:sldId id="271" r:id="rId15"/>
+    <p:sldId id="272" r:id="rId16"/>
+    <p:sldId id="268" r:id="rId17"/>
+    <p:sldId id="273" r:id="rId18"/>
+    <p:sldId id="269" r:id="rId19"/>
   </p:sldIdLst>
   <p:sldSz cx="12192000" cy="6858000"/>
   <p:notesSz cx="6858000" cy="9144000"/>
@@ -272,7 +276,7 @@
           <a:p>
             <a:fld id="{0A9A78ED-B98F-42E9-8346-8CC44BF90042}" type="datetimeFigureOut">
               <a:rPr lang="en-US" smtClean="0"/>
-              <a:t>2/26/26</a:t>
+              <a:t>3/1/2026</a:t>
             </a:fld>
             <a:endParaRPr lang="en-US"/>
           </a:p>
@@ -470,7 +474,7 @@
           <a:p>
             <a:fld id="{0A9A78ED-B98F-42E9-8346-8CC44BF90042}" type="datetimeFigureOut">
               <a:rPr lang="en-US" smtClean="0"/>
-              <a:t>2/26/26</a:t>
+              <a:t>3/1/2026</a:t>
             </a:fld>
             <a:endParaRPr lang="en-US"/>
           </a:p>
@@ -678,7 +682,7 @@
           <a:p>
             <a:fld id="{0A9A78ED-B98F-42E9-8346-8CC44BF90042}" type="datetimeFigureOut">
               <a:rPr lang="en-US" smtClean="0"/>
-              <a:t>2/26/26</a:t>
+              <a:t>3/1/2026</a:t>
             </a:fld>
             <a:endParaRPr lang="en-US"/>
           </a:p>
@@ -876,7 +880,7 @@
           <a:p>
             <a:fld id="{0A9A78ED-B98F-42E9-8346-8CC44BF90042}" type="datetimeFigureOut">
               <a:rPr lang="en-US" smtClean="0"/>
-              <a:t>2/26/26</a:t>
+              <a:t>3/1/2026</a:t>
             </a:fld>
             <a:endParaRPr lang="en-US"/>
           </a:p>
@@ -1151,7 +1155,7 @@
           <a:p>
             <a:fld id="{0A9A78ED-B98F-42E9-8346-8CC44BF90042}" type="datetimeFigureOut">
               <a:rPr lang="en-US" smtClean="0"/>
-              <a:t>2/26/26</a:t>
+              <a:t>3/1/2026</a:t>
             </a:fld>
             <a:endParaRPr lang="en-US"/>
           </a:p>
@@ -1416,7 +1420,7 @@
           <a:p>
             <a:fld id="{0A9A78ED-B98F-42E9-8346-8CC44BF90042}" type="datetimeFigureOut">
               <a:rPr lang="en-US" smtClean="0"/>
-              <a:t>2/26/26</a:t>
+              <a:t>3/1/2026</a:t>
             </a:fld>
             <a:endParaRPr lang="en-US"/>
           </a:p>
@@ -1828,7 +1832,7 @@
           <a:p>
             <a:fld id="{0A9A78ED-B98F-42E9-8346-8CC44BF90042}" type="datetimeFigureOut">
               <a:rPr lang="en-US" smtClean="0"/>
-              <a:t>2/26/26</a:t>
+              <a:t>3/1/2026</a:t>
             </a:fld>
             <a:endParaRPr lang="en-US"/>
           </a:p>
@@ -1969,7 +1973,7 @@
           <a:p>
             <a:fld id="{0A9A78ED-B98F-42E9-8346-8CC44BF90042}" type="datetimeFigureOut">
               <a:rPr lang="en-US" smtClean="0"/>
-              <a:t>2/26/26</a:t>
+              <a:t>3/1/2026</a:t>
             </a:fld>
             <a:endParaRPr lang="en-US"/>
           </a:p>
@@ -2082,7 +2086,7 @@
           <a:p>
             <a:fld id="{0A9A78ED-B98F-42E9-8346-8CC44BF90042}" type="datetimeFigureOut">
               <a:rPr lang="en-US" smtClean="0"/>
-              <a:t>2/26/26</a:t>
+              <a:t>3/1/2026</a:t>
             </a:fld>
             <a:endParaRPr lang="en-US"/>
           </a:p>
@@ -2393,7 +2397,7 @@
           <a:p>
             <a:fld id="{0A9A78ED-B98F-42E9-8346-8CC44BF90042}" type="datetimeFigureOut">
               <a:rPr lang="en-US" smtClean="0"/>
-              <a:t>2/26/26</a:t>
+              <a:t>3/1/2026</a:t>
             </a:fld>
             <a:endParaRPr lang="en-US"/>
           </a:p>
@@ -2681,7 +2685,7 @@
           <a:p>
             <a:fld id="{0A9A78ED-B98F-42E9-8346-8CC44BF90042}" type="datetimeFigureOut">
               <a:rPr lang="en-US" smtClean="0"/>
-              <a:t>2/26/26</a:t>
+              <a:t>3/1/2026</a:t>
             </a:fld>
             <a:endParaRPr lang="en-US"/>
           </a:p>
@@ -2922,7 +2926,7 @@
           <a:p>
             <a:fld id="{0A9A78ED-B98F-42E9-8346-8CC44BF90042}" type="datetimeFigureOut">
               <a:rPr lang="en-US" smtClean="0"/>
-              <a:t>2/26/26</a:t>
+              <a:t>3/1/2026</a:t>
             </a:fld>
             <a:endParaRPr lang="en-US"/>
           </a:p>
@@ -3780,6 +3784,398 @@
           <p:cNvPr id="2" name="Title 1">
             <a:extLst>
               <a:ext uri="{FF2B5EF4-FFF2-40B4-BE49-F238E27FC236}">
+                <a16:creationId xmlns:a16="http://schemas.microsoft.com/office/drawing/2014/main" id="{D96D5D28-BC79-E372-7429-BA9CC9886B0A}"/>
+              </a:ext>
+            </a:extLst>
+          </p:cNvPr>
+          <p:cNvSpPr>
+            <a:spLocks noGrp="1"/>
+          </p:cNvSpPr>
+          <p:nvPr>
+            <p:ph type="title"/>
+          </p:nvPr>
+        </p:nvSpPr>
+        <p:spPr>
+          <a:xfrm>
+            <a:off x="838200" y="81593"/>
+            <a:ext cx="10515600" cy="1325563"/>
+          </a:xfrm>
+        </p:spPr>
+        <p:txBody>
+          <a:bodyPr/>
+          <a:lstStyle/>
+          <a:p>
+            <a:r>
+              <a:rPr lang="en-US" dirty="0"/>
+              <a:t>Standardized NGAL from Baseline Over Time for AKI and no AKI populations</a:t>
+            </a:r>
+          </a:p>
+        </p:txBody>
+      </p:sp>
+      <p:pic>
+        <p:nvPicPr>
+          <p:cNvPr id="5" name="Content Placeholder 4">
+            <a:extLst>
+              <a:ext uri="{FF2B5EF4-FFF2-40B4-BE49-F238E27FC236}">
+                <a16:creationId xmlns:a16="http://schemas.microsoft.com/office/drawing/2014/main" id="{8EB16B30-3637-1169-5D80-FCB398650AD8}"/>
+              </a:ext>
+            </a:extLst>
+          </p:cNvPr>
+          <p:cNvPicPr>
+            <a:picLocks noGrp="1" noChangeAspect="1"/>
+          </p:cNvPicPr>
+          <p:nvPr>
+            <p:ph idx="1"/>
+          </p:nvPr>
+        </p:nvPicPr>
+        <p:blipFill>
+          <a:blip r:embed="rId2">
+            <a:extLst>
+              <a:ext uri="{28A0092B-C50C-407E-A947-70E740481C1C}">
+                <a14:useLocalDpi xmlns:a14="http://schemas.microsoft.com/office/drawing/2010/main" val="0"/>
+              </a:ext>
+            </a:extLst>
+          </a:blip>
+          <a:stretch>
+            <a:fillRect/>
+          </a:stretch>
+        </p:blipFill>
+        <p:spPr>
+          <a:xfrm>
+            <a:off x="6367501" y="1359297"/>
+            <a:ext cx="5417110" cy="5417110"/>
+          </a:xfrm>
+        </p:spPr>
+      </p:pic>
+      <p:pic>
+        <p:nvPicPr>
+          <p:cNvPr id="7" name="Picture 6">
+            <a:extLst>
+              <a:ext uri="{FF2B5EF4-FFF2-40B4-BE49-F238E27FC236}">
+                <a16:creationId xmlns:a16="http://schemas.microsoft.com/office/drawing/2014/main" id="{2E917B1D-916B-FCDC-31A9-46737819E761}"/>
+              </a:ext>
+            </a:extLst>
+          </p:cNvPr>
+          <p:cNvPicPr>
+            <a:picLocks noChangeAspect="1"/>
+          </p:cNvPicPr>
+          <p:nvPr/>
+        </p:nvPicPr>
+        <p:blipFill>
+          <a:blip r:embed="rId3">
+            <a:extLst>
+              <a:ext uri="{28A0092B-C50C-407E-A947-70E740481C1C}">
+                <a14:useLocalDpi xmlns:a14="http://schemas.microsoft.com/office/drawing/2010/main" val="0"/>
+              </a:ext>
+            </a:extLst>
+          </a:blip>
+          <a:stretch>
+            <a:fillRect/>
+          </a:stretch>
+        </p:blipFill>
+        <p:spPr>
+          <a:xfrm>
+            <a:off x="580536" y="1359297"/>
+            <a:ext cx="5417110" cy="5417110"/>
+          </a:xfrm>
+          <a:prstGeom prst="rect">
+            <a:avLst/>
+          </a:prstGeom>
+        </p:spPr>
+      </p:pic>
+    </p:spTree>
+    <p:extLst>
+      <p:ext uri="{BB962C8B-B14F-4D97-AF65-F5344CB8AC3E}">
+        <p14:creationId xmlns:p14="http://schemas.microsoft.com/office/powerpoint/2010/main" val="751323211"/>
+      </p:ext>
+    </p:extLst>
+  </p:cSld>
+  <p:clrMapOvr>
+    <a:masterClrMapping/>
+  </p:clrMapOvr>
+</p:sld>
+</file>
+
+<file path=ppt/slides/slide14.xml><?xml version="1.0" encoding="utf-8"?>
+<p:sld xmlns:a="http://schemas.openxmlformats.org/drawingml/2006/main" xmlns:r="http://schemas.openxmlformats.org/officeDocument/2006/relationships" xmlns:p="http://schemas.openxmlformats.org/presentationml/2006/main">
+  <p:cSld>
+    <p:spTree>
+      <p:nvGrpSpPr>
+        <p:cNvPr id="1" name=""/>
+        <p:cNvGrpSpPr/>
+        <p:nvPr/>
+      </p:nvGrpSpPr>
+      <p:grpSpPr>
+        <a:xfrm>
+          <a:off x="0" y="0"/>
+          <a:ext cx="0" cy="0"/>
+          <a:chOff x="0" y="0"/>
+          <a:chExt cx="0" cy="0"/>
+        </a:xfrm>
+      </p:grpSpPr>
+      <p:sp>
+        <p:nvSpPr>
+          <p:cNvPr id="2" name="Title 1">
+            <a:extLst>
+              <a:ext uri="{FF2B5EF4-FFF2-40B4-BE49-F238E27FC236}">
+                <a16:creationId xmlns:a16="http://schemas.microsoft.com/office/drawing/2014/main" id="{F6026BF2-0B08-A871-45F3-11B2C194FA76}"/>
+              </a:ext>
+            </a:extLst>
+          </p:cNvPr>
+          <p:cNvSpPr>
+            <a:spLocks noGrp="1"/>
+          </p:cNvSpPr>
+          <p:nvPr>
+            <p:ph type="title"/>
+          </p:nvPr>
+        </p:nvSpPr>
+        <p:spPr/>
+        <p:txBody>
+          <a:bodyPr/>
+          <a:lstStyle/>
+          <a:p>
+            <a:r>
+              <a:rPr lang="en-US" dirty="0"/>
+              <a:t>Standardized NGAL from Baseline Over Time for AKI and no AKI populations</a:t>
+            </a:r>
+          </a:p>
+        </p:txBody>
+      </p:sp>
+      <p:pic>
+        <p:nvPicPr>
+          <p:cNvPr id="5" name="Content Placeholder 4">
+            <a:extLst>
+              <a:ext uri="{FF2B5EF4-FFF2-40B4-BE49-F238E27FC236}">
+                <a16:creationId xmlns:a16="http://schemas.microsoft.com/office/drawing/2014/main" id="{F0929F5F-FEAA-CFF7-9916-DE0B0A9E5C00}"/>
+              </a:ext>
+            </a:extLst>
+          </p:cNvPr>
+          <p:cNvPicPr>
+            <a:picLocks noGrp="1" noChangeAspect="1"/>
+          </p:cNvPicPr>
+          <p:nvPr>
+            <p:ph idx="1"/>
+          </p:nvPr>
+        </p:nvPicPr>
+        <p:blipFill>
+          <a:blip r:embed="rId2">
+            <a:extLst>
+              <a:ext uri="{28A0092B-C50C-407E-A947-70E740481C1C}">
+                <a14:useLocalDpi xmlns:a14="http://schemas.microsoft.com/office/drawing/2010/main" val="0"/>
+              </a:ext>
+            </a:extLst>
+          </a:blip>
+          <a:stretch>
+            <a:fillRect/>
+          </a:stretch>
+        </p:blipFill>
+        <p:spPr>
+          <a:xfrm>
+            <a:off x="773205" y="1763227"/>
+            <a:ext cx="5044499" cy="5044499"/>
+          </a:xfrm>
+        </p:spPr>
+      </p:pic>
+      <p:pic>
+        <p:nvPicPr>
+          <p:cNvPr id="7" name="Picture 6">
+            <a:extLst>
+              <a:ext uri="{FF2B5EF4-FFF2-40B4-BE49-F238E27FC236}">
+                <a16:creationId xmlns:a16="http://schemas.microsoft.com/office/drawing/2014/main" id="{E0FA5CC3-63F0-53E2-03DE-A81441D1B03C}"/>
+              </a:ext>
+            </a:extLst>
+          </p:cNvPr>
+          <p:cNvPicPr>
+            <a:picLocks noChangeAspect="1"/>
+          </p:cNvPicPr>
+          <p:nvPr/>
+        </p:nvPicPr>
+        <p:blipFill>
+          <a:blip r:embed="rId3">
+            <a:extLst>
+              <a:ext uri="{28A0092B-C50C-407E-A947-70E740481C1C}">
+                <a14:useLocalDpi xmlns:a14="http://schemas.microsoft.com/office/drawing/2010/main" val="0"/>
+              </a:ext>
+            </a:extLst>
+          </a:blip>
+          <a:stretch>
+            <a:fillRect/>
+          </a:stretch>
+        </p:blipFill>
+        <p:spPr>
+          <a:xfrm>
+            <a:off x="6309301" y="1763226"/>
+            <a:ext cx="5044499" cy="5044499"/>
+          </a:xfrm>
+          <a:prstGeom prst="rect">
+            <a:avLst/>
+          </a:prstGeom>
+        </p:spPr>
+      </p:pic>
+    </p:spTree>
+    <p:extLst>
+      <p:ext uri="{BB962C8B-B14F-4D97-AF65-F5344CB8AC3E}">
+        <p14:creationId xmlns:p14="http://schemas.microsoft.com/office/powerpoint/2010/main" val="692600500"/>
+      </p:ext>
+    </p:extLst>
+  </p:cSld>
+  <p:clrMapOvr>
+    <a:masterClrMapping/>
+  </p:clrMapOvr>
+</p:sld>
+</file>
+
+<file path=ppt/slides/slide15.xml><?xml version="1.0" encoding="utf-8"?>
+<p:sld xmlns:a="http://schemas.openxmlformats.org/drawingml/2006/main" xmlns:r="http://schemas.openxmlformats.org/officeDocument/2006/relationships" xmlns:p="http://schemas.openxmlformats.org/presentationml/2006/main">
+  <p:cSld>
+    <p:spTree>
+      <p:nvGrpSpPr>
+        <p:cNvPr id="1" name=""/>
+        <p:cNvGrpSpPr/>
+        <p:nvPr/>
+      </p:nvGrpSpPr>
+      <p:grpSpPr>
+        <a:xfrm>
+          <a:off x="0" y="0"/>
+          <a:ext cx="0" cy="0"/>
+          <a:chOff x="0" y="0"/>
+          <a:chExt cx="0" cy="0"/>
+        </a:xfrm>
+      </p:grpSpPr>
+      <p:sp>
+        <p:nvSpPr>
+          <p:cNvPr id="2" name="Title 1">
+            <a:extLst>
+              <a:ext uri="{FF2B5EF4-FFF2-40B4-BE49-F238E27FC236}">
+                <a16:creationId xmlns:a16="http://schemas.microsoft.com/office/drawing/2014/main" id="{DE120239-AA03-957E-0098-52A860E40A1B}"/>
+              </a:ext>
+            </a:extLst>
+          </p:cNvPr>
+          <p:cNvSpPr>
+            <a:spLocks noGrp="1"/>
+          </p:cNvSpPr>
+          <p:nvPr>
+            <p:ph type="title"/>
+          </p:nvPr>
+        </p:nvSpPr>
+        <p:spPr/>
+        <p:txBody>
+          <a:bodyPr/>
+          <a:lstStyle/>
+          <a:p>
+            <a:r>
+              <a:rPr lang="en-US" dirty="0"/>
+              <a:t>Standardized NGAL at T4 for AKI and no AKI populations</a:t>
+            </a:r>
+          </a:p>
+        </p:txBody>
+      </p:sp>
+      <p:pic>
+        <p:nvPicPr>
+          <p:cNvPr id="5" name="Content Placeholder 4">
+            <a:extLst>
+              <a:ext uri="{FF2B5EF4-FFF2-40B4-BE49-F238E27FC236}">
+                <a16:creationId xmlns:a16="http://schemas.microsoft.com/office/drawing/2014/main" id="{B466939C-DA2B-820B-5C89-5724C72A5E3A}"/>
+              </a:ext>
+            </a:extLst>
+          </p:cNvPr>
+          <p:cNvPicPr>
+            <a:picLocks noGrp="1" noChangeAspect="1"/>
+          </p:cNvPicPr>
+          <p:nvPr>
+            <p:ph idx="1"/>
+          </p:nvPr>
+        </p:nvPicPr>
+        <p:blipFill>
+          <a:blip r:embed="rId2">
+            <a:extLst>
+              <a:ext uri="{28A0092B-C50C-407E-A947-70E740481C1C}">
+                <a14:useLocalDpi xmlns:a14="http://schemas.microsoft.com/office/drawing/2010/main" val="0"/>
+              </a:ext>
+            </a:extLst>
+          </a:blip>
+          <a:stretch>
+            <a:fillRect/>
+          </a:stretch>
+        </p:blipFill>
+        <p:spPr>
+          <a:xfrm>
+            <a:off x="6311186" y="1690688"/>
+            <a:ext cx="4802187" cy="4802187"/>
+          </a:xfrm>
+        </p:spPr>
+      </p:pic>
+      <p:pic>
+        <p:nvPicPr>
+          <p:cNvPr id="7" name="Picture 6">
+            <a:extLst>
+              <a:ext uri="{FF2B5EF4-FFF2-40B4-BE49-F238E27FC236}">
+                <a16:creationId xmlns:a16="http://schemas.microsoft.com/office/drawing/2014/main" id="{20DA9EA1-979B-B87C-0C22-135E81FF227C}"/>
+              </a:ext>
+            </a:extLst>
+          </p:cNvPr>
+          <p:cNvPicPr>
+            <a:picLocks noChangeAspect="1"/>
+          </p:cNvPicPr>
+          <p:nvPr/>
+        </p:nvPicPr>
+        <p:blipFill>
+          <a:blip r:embed="rId3">
+            <a:extLst>
+              <a:ext uri="{28A0092B-C50C-407E-A947-70E740481C1C}">
+                <a14:useLocalDpi xmlns:a14="http://schemas.microsoft.com/office/drawing/2010/main" val="0"/>
+              </a:ext>
+            </a:extLst>
+          </a:blip>
+          <a:stretch>
+            <a:fillRect/>
+          </a:stretch>
+        </p:blipFill>
+        <p:spPr>
+          <a:xfrm>
+            <a:off x="838199" y="1632640"/>
+            <a:ext cx="4860235" cy="4860235"/>
+          </a:xfrm>
+          <a:prstGeom prst="rect">
+            <a:avLst/>
+          </a:prstGeom>
+        </p:spPr>
+      </p:pic>
+    </p:spTree>
+    <p:extLst>
+      <p:ext uri="{BB962C8B-B14F-4D97-AF65-F5344CB8AC3E}">
+        <p14:creationId xmlns:p14="http://schemas.microsoft.com/office/powerpoint/2010/main" val="1460671149"/>
+      </p:ext>
+    </p:extLst>
+  </p:cSld>
+  <p:clrMapOvr>
+    <a:masterClrMapping/>
+  </p:clrMapOvr>
+</p:sld>
+</file>
+
+<file path=ppt/slides/slide16.xml><?xml version="1.0" encoding="utf-8"?>
+<p:sld xmlns:a="http://schemas.openxmlformats.org/drawingml/2006/main" xmlns:r="http://schemas.openxmlformats.org/officeDocument/2006/relationships" xmlns:p="http://schemas.openxmlformats.org/presentationml/2006/main">
+  <p:cSld>
+    <p:spTree>
+      <p:nvGrpSpPr>
+        <p:cNvPr id="1" name=""/>
+        <p:cNvGrpSpPr/>
+        <p:nvPr/>
+      </p:nvGrpSpPr>
+      <p:grpSpPr>
+        <a:xfrm>
+          <a:off x="0" y="0"/>
+          <a:ext cx="0" cy="0"/>
+          <a:chOff x="0" y="0"/>
+          <a:chExt cx="0" cy="0"/>
+        </a:xfrm>
+      </p:grpSpPr>
+      <p:sp>
+        <p:nvSpPr>
+          <p:cNvPr id="2" name="Title 1">
+            <a:extLst>
+              <a:ext uri="{FF2B5EF4-FFF2-40B4-BE49-F238E27FC236}">
                 <a16:creationId xmlns:a16="http://schemas.microsoft.com/office/drawing/2014/main" id="{296B5EF6-AD4E-DB4C-28E5-17C07B557861}"/>
               </a:ext>
             </a:extLst>
@@ -3868,7 +4264,128 @@
 </p:sld>
 </file>
 
-<file path=ppt/slides/slide14.xml><?xml version="1.0" encoding="utf-8"?>
+<file path=ppt/slides/slide17.xml><?xml version="1.0" encoding="utf-8"?>
+<p:sld xmlns:a="http://schemas.openxmlformats.org/drawingml/2006/main" xmlns:r="http://schemas.openxmlformats.org/officeDocument/2006/relationships" xmlns:p="http://schemas.openxmlformats.org/presentationml/2006/main">
+  <p:cSld>
+    <p:spTree>
+      <p:nvGrpSpPr>
+        <p:cNvPr id="1" name="">
+          <a:extLst>
+            <a:ext uri="{FF2B5EF4-FFF2-40B4-BE49-F238E27FC236}">
+              <a16:creationId xmlns:a16="http://schemas.microsoft.com/office/drawing/2014/main" id="{12B2378D-D535-BF74-8423-9FC7090B2C80}"/>
+            </a:ext>
+          </a:extLst>
+        </p:cNvPr>
+        <p:cNvGrpSpPr/>
+        <p:nvPr/>
+      </p:nvGrpSpPr>
+      <p:grpSpPr>
+        <a:xfrm>
+          <a:off x="0" y="0"/>
+          <a:ext cx="0" cy="0"/>
+          <a:chOff x="0" y="0"/>
+          <a:chExt cx="0" cy="0"/>
+        </a:xfrm>
+      </p:grpSpPr>
+      <p:sp>
+        <p:nvSpPr>
+          <p:cNvPr id="2" name="Title 1">
+            <a:extLst>
+              <a:ext uri="{FF2B5EF4-FFF2-40B4-BE49-F238E27FC236}">
+                <a16:creationId xmlns:a16="http://schemas.microsoft.com/office/drawing/2014/main" id="{16A259C6-6E79-930F-5DC3-3F5B18F8A2E9}"/>
+              </a:ext>
+            </a:extLst>
+          </p:cNvPr>
+          <p:cNvSpPr>
+            <a:spLocks noGrp="1"/>
+          </p:cNvSpPr>
+          <p:nvPr>
+            <p:ph type="title"/>
+          </p:nvPr>
+        </p:nvSpPr>
+        <p:spPr/>
+        <p:txBody>
+          <a:bodyPr/>
+          <a:lstStyle/>
+          <a:p>
+            <a:r>
+              <a:rPr lang="en-US" dirty="0"/>
+              <a:t>Mediation Analysis when using standardized NGAL at T4 as the mediating variable</a:t>
+            </a:r>
+          </a:p>
+        </p:txBody>
+      </p:sp>
+      <p:sp>
+        <p:nvSpPr>
+          <p:cNvPr id="3" name="Content Placeholder 2">
+            <a:extLst>
+              <a:ext uri="{FF2B5EF4-FFF2-40B4-BE49-F238E27FC236}">
+                <a16:creationId xmlns:a16="http://schemas.microsoft.com/office/drawing/2014/main" id="{683676C5-DBC8-A151-C977-C2C888850D9A}"/>
+              </a:ext>
+            </a:extLst>
+          </p:cNvPr>
+          <p:cNvSpPr>
+            <a:spLocks noGrp="1"/>
+          </p:cNvSpPr>
+          <p:nvPr>
+            <p:ph idx="1"/>
+          </p:nvPr>
+        </p:nvSpPr>
+        <p:spPr/>
+        <p:txBody>
+          <a:bodyPr/>
+          <a:lstStyle/>
+          <a:p>
+            <a:r>
+              <a:rPr lang="en-US" dirty="0"/>
+              <a:t>Analysis of effect of hypoxia on AKI when NGAL is the mediating variable</a:t>
+            </a:r>
+          </a:p>
+          <a:p>
+            <a:r>
+              <a:rPr lang="en-US" dirty="0"/>
+              <a:t>Total effect: 0.16 (0.00, 0.33)</a:t>
+            </a:r>
+          </a:p>
+          <a:p>
+            <a:r>
+              <a:rPr lang="en-US" dirty="0"/>
+              <a:t>Indirect effect: -0.07 (-0.31, 0.15)</a:t>
+            </a:r>
+          </a:p>
+          <a:p>
+            <a:r>
+              <a:rPr lang="en-US" dirty="0"/>
+              <a:t>Direct effect</a:t>
+            </a:r>
+            <a:r>
+              <a:rPr lang="en-US"/>
+              <a:t>: 0.23 (0.06, 0.43)</a:t>
+            </a:r>
+            <a:endParaRPr lang="en-US" dirty="0"/>
+          </a:p>
+          <a:p>
+            <a:endParaRPr lang="en-US" dirty="0"/>
+          </a:p>
+          <a:p>
+            <a:endParaRPr lang="en-US" dirty="0"/>
+          </a:p>
+        </p:txBody>
+      </p:sp>
+    </p:spTree>
+    <p:extLst>
+      <p:ext uri="{BB962C8B-B14F-4D97-AF65-F5344CB8AC3E}">
+        <p14:creationId xmlns:p14="http://schemas.microsoft.com/office/powerpoint/2010/main" val="3699508898"/>
+      </p:ext>
+    </p:extLst>
+  </p:cSld>
+  <p:clrMapOvr>
+    <a:masterClrMapping/>
+  </p:clrMapOvr>
+</p:sld>
+</file>
+
+<file path=ppt/slides/slide18.xml><?xml version="1.0" encoding="utf-8"?>
 <p:sld xmlns:a="http://schemas.openxmlformats.org/drawingml/2006/main" xmlns:r="http://schemas.openxmlformats.org/officeDocument/2006/relationships" xmlns:p="http://schemas.openxmlformats.org/presentationml/2006/main">
   <p:cSld>
     <p:spTree>

</xml_diff>